<commit_message>
Refocus portal, DB, slides, and memos entirely on data privacy and KDPA compliance, removing financial audits
</commit_message>
<xml_diff>
--- a/presentation_slides.pptx
+++ b/presentation_slides.pptx
@@ -3158,7 +3158,7 @@
               </a:defRPr>
             </a:pPr>
             <a:r>
-              <a:t>Securing Beneficiary Data Rights (KDPA) &amp; Stipend Disbursement Integrity</a:t>
+              <a:t>Securing Beneficiary Data Rights (KDPA) &amp; Compliance Operations</a:t>
             </a:r>
           </a:p>
           <a:p>
@@ -3259,7 +3259,7 @@
               </a:defRPr>
             </a:pPr>
             <a:r>
-              <a:t>Balancing Digitization with Privacy &amp; Donor Audits</a:t>
+              <a:t>Digitizing Beneficiary Records Safely</a:t>
             </a:r>
           </a:p>
         </p:txBody>
@@ -3298,7 +3298,7 @@
               </a:defRPr>
             </a:pPr>
             <a:r>
-              <a:t>1. PII Exposure Risk: Sharing contact details (Names, National IDs, phones, emails) in raw files violates core KDPA data minimization principles.</a:t>
+              <a:t>1. PII Exposure Risk: Sharing contact details (Names, National IDs, phones, emails) in raw files with coordinators and donors violates data minimization laws.</a:t>
             </a:r>
           </a:p>
           <a:p>
@@ -3314,7 +3314,7 @@
               </a:defRPr>
             </a:pPr>
             <a:r>
-              <a:t>2. Ingestion Quality Control: Missing fields, wrong formats, or out-of-bounds regions in field data leads to corrupted database entries.</a:t>
+              <a:t>2. Ingestion Quality Control: Registrations submitted from the field often contain syntax errors, missing signatures, or wrong formats.</a:t>
             </a:r>
           </a:p>
           <a:p>
@@ -3330,7 +3330,7 @@
               </a:defRPr>
             </a:pPr>
             <a:r>
-              <a:t>3. Stipend Payout Leakage: Manual reconciliation of monthly stipends (KES 5,000/month) against attendance logs is slow and prone to over-payments.</a:t>
+              <a:t>3. Rights Execution Latency: Manually processing beneficiary requests to verify, withdraw, or delete profiles ('Right to be Forgotten' under Section 40) takes up to 14 business days.</a:t>
             </a:r>
           </a:p>
         </p:txBody>
@@ -3711,7 +3711,7 @@
               </a:defRPr>
             </a:pPr>
             <a:r>
-              <a:t>Slide 5: Automated Financial Reconciliation</a:t>
+              <a:t>Slide 5: Chatbot Rights Engine &amp; Exporter</a:t>
             </a:r>
           </a:p>
           <a:p>
@@ -3724,7 +3724,7 @@
               </a:defRPr>
             </a:pPr>
             <a:r>
-              <a:t>Restoring Funding Integrity (Stipend vs. Attendance Audits)</a:t>
+              <a:t>Automated Consent Control &amp; Audits</a:t>
             </a:r>
           </a:p>
         </p:txBody>
@@ -3763,7 +3763,7 @@
               </a:defRPr>
             </a:pPr>
             <a:r>
-              <a:t>Stipend Policy Enforcement: Verifies minimum 75% attendance rate and active data consent before authorizing stipend payouts.</a:t>
+              <a:t>Bilingual Rights Agent: Handles data requests in Swahili and English. Allows fellows to check profile details, update consent purposes, or execute data purges.</a:t>
             </a:r>
           </a:p>
           <a:p>
@@ -3779,7 +3779,7 @@
               </a:defRPr>
             </a:pPr>
             <a:r>
-              <a:t>Reconciliation Auditing: Compares actual disbursements against expected amounts based on attendance sheets in SQLite.</a:t>
+              <a:t>External Compliant Export: A prominent Export Compliant Donor Report (CSV) button allows compliance auditors to instantly download masked, donor-safe datasets for external audits.</a:t>
             </a:r>
           </a:p>
           <a:p>
@@ -3795,7 +3795,7 @@
               </a:defRPr>
             </a:pPr>
             <a:r>
-              <a:t>1-Click Correction: Flags over-payment discrepancies and offers a single-click button to recall payouts and suspend active enrollments.</a:t>
+              <a:t>Direct Self-Service: Beneficiaries log in directly to adjust permissions for Stipends, Photos, SMS, or Audits.</a:t>
             </a:r>
           </a:p>
         </p:txBody>
@@ -3879,7 +3879,7 @@
               </a:defRPr>
             </a:pPr>
             <a:r>
-              <a:t>Strategic Operational &amp; Financial Benefits Summary</a:t>
+              <a:t>Strategic Operational &amp; Compliance Benefits Summary</a:t>
             </a:r>
           </a:p>
         </p:txBody>
@@ -3934,7 +3934,7 @@
               </a:defRPr>
             </a:pPr>
             <a:r>
-              <a:t>Audit Speed: Reduces monthly stipend reconciliation from 15 hours to less than 1 minute using the portal auditing widget.</a:t>
+              <a:t>Rights SLA Compliance: Reduces profile erasure ('Right to be Forgotten') cycle times from 14 business days to less than 1 second.</a:t>
             </a:r>
           </a:p>
           <a:p>
@@ -3950,7 +3950,7 @@
               </a:defRPr>
             </a:pPr>
             <a:r>
-              <a:t>Direct Payout Recovery: Flags 8 over-payment anomalies, saving KES 40,000.00/month (projected KES 480,000.00/year).</a:t>
+              <a:t>Zero-Pollution Boundary: Quarantines registrations containing bad formats before they write to active directory.</a:t>
             </a:r>
           </a:p>
           <a:p>

</xml_diff>